<commit_message>
Add PIO explanation slide with BCM validation waveform
- New slide 3: PIO-driven BCM scanning step-by-step explanation
  (trigger → row GPIO → PIO 4 bit-planes → idle)
- Embedded Saleae pulse-average image (499 pulses at 50 MHz)
  showing B0/B1/B2/B3 bit-plane structure in photodiode signal
- Now 5 slides: title, architecture, PIO+validation, results, next steps

Co-Authored-By: Claude Opus 4.6 (1M context) <noreply@anthropic.com>
</commit_message>
<xml_diff>
--- a/test_firmware/single_led/G6_Timing_Summary.pptx
+++ b/test_firmware/single_led/G6_Timing_Summary.pptx
@@ -9,9 +9,10 @@
     <p:sldId id="257" r:id="rId3"/>
     <p:sldId id="258" r:id="rId4"/>
     <p:sldId id="259" r:id="rId5"/>
+    <p:sldId id="260" r:id="rId6"/>
   </p:sldIdLst>
   <p:notesMasterIdLst>
-    <p:notesMasterId r:id="rId6"/>
+    <p:notesMasterId r:id="rId7"/>
   </p:notesMasterIdLst>
   <p:sldSz cx="9144000" cy="5143500"/>
   <p:notesSz cx="5143500" cy="9144000"/>
@@ -793,6 +794,94 @@
             <a:fld id="{F7021451-1387-4CA6-816F-3879F97B5CBC}" type="slidenum">
               <a:rPr lang="en-US"/>
               <a:t>4</a:t>
+            </a:fld>
+            <a:endParaRPr lang="en-US"/>
+          </a:p>
+        </p:txBody>
+      </p:sp>
+    </p:spTree>
+    <p:extLst>
+      <p:ext uri="{BB962C8B-B14F-4D97-AF65-F5344CB8AC3E}">
+        <p14:creationId xmlns:p14="http://schemas.microsoft.com/office/powerpoint/2010/main" val="1024086991"/>
+      </p:ext>
+    </p:extLst>
+  </p:cSld>
+  <p:clrMapOvr>
+    <a:masterClrMapping/>
+  </p:clrMapOvr>
+</p:notes>
+</file>
+
+<file path=ppt/notesSlides/notesSlide5.xml><?xml version="1.0" encoding="utf-8"?>
+<p:notes xmlns:a="http://schemas.openxmlformats.org/drawingml/2006/main" xmlns:r="http://schemas.openxmlformats.org/officeDocument/2006/relationships" xmlns:p="http://schemas.openxmlformats.org/presentationml/2006/main">
+  <p:cSld>
+    <p:spTree>
+      <p:nvGrpSpPr>
+        <p:cNvPr id="1" name=""/>
+        <p:cNvGrpSpPr/>
+        <p:nvPr/>
+      </p:nvGrpSpPr>
+      <p:grpSpPr>
+        <a:xfrm>
+          <a:off x="0" y="0"/>
+          <a:ext cx="0" cy="0"/>
+          <a:chOff x="0" y="0"/>
+          <a:chExt cx="0" cy="0"/>
+        </a:xfrm>
+      </p:grpSpPr>
+      <p:sp>
+        <p:nvSpPr>
+          <p:cNvPr id="2" name="Slide Image Placeholder 1"/>
+          <p:cNvSpPr>
+            <a:spLocks noGrp="1" noRot="1" noChangeAspect="1"/>
+          </p:cNvSpPr>
+          <p:nvPr>
+            <p:ph type="sldImg"/>
+          </p:nvPr>
+        </p:nvSpPr>
+        <p:spPr/>
+      </p:sp>
+      <p:sp>
+        <p:nvSpPr>
+          <p:cNvPr id="3" name="Notes Placeholder 2"/>
+          <p:cNvSpPr>
+            <a:spLocks noGrp="1"/>
+          </p:cNvSpPr>
+          <p:nvPr>
+            <p:ph type="body" idx="1"/>
+          </p:nvPr>
+        </p:nvSpPr>
+        <p:spPr/>
+        <p:txBody>
+          <a:bodyPr/>
+          <a:lstStyle/>
+          <a:p>
+            <a:r>
+              <a:rPr lang="en-US" dirty="0"/>
+              <a:t/>
+            </a:r>
+            <a:endParaRPr lang="en-US" dirty="0"/>
+          </a:p>
+        </p:txBody>
+      </p:sp>
+      <p:sp>
+        <p:nvSpPr>
+          <p:cNvPr id="4" name="Slide Number Placeholder 3"/>
+          <p:cNvSpPr>
+            <a:spLocks noGrp="1"/>
+          </p:cNvSpPr>
+          <p:nvPr>
+            <p:ph type="sldNum" sz="quarter" idx="10"/>
+          </p:nvPr>
+        </p:nvSpPr>
+        <p:spPr/>
+        <p:txBody>
+          <a:bodyPr/>
+          <a:lstStyle/>
+          <a:p>
+            <a:fld id="{F7021451-1387-4CA6-816F-3879F97B5CBC}" type="slidenum">
+              <a:rPr lang="en-US"/>
+              <a:t>5</a:t>
             </a:fld>
             <a:endParaRPr lang="en-US"/>
           </a:p>
@@ -2990,7 +3079,7 @@
                 <a:ea typeface="Arial Black" pitchFamily="34" charset="-122"/>
                 <a:cs typeface="Arial Black" pitchFamily="34" charset="-120"/>
               </a:rPr>
-              <a:t>BCM Burst Timing — All Configurations</a:t>
+              <a:t>PIO-Driven BCM Scanning</a:t>
             </a:r>
             <a:endParaRPr lang="en-US" sz="3200" dirty="0"/>
           </a:p>
@@ -3029,6 +3118,1235 @@
                 <a:ea typeface="Calibri" pitchFamily="34" charset="-122"/>
                 <a:cs typeface="Calibri" pitchFamily="34" charset="-120"/>
               </a:rPr>
+              <a:t>Hardware-timed column patterns via RP2350 Programmable I/O</a:t>
+            </a:r>
+            <a:endParaRPr lang="en-US" sz="1400" dirty="0"/>
+          </a:p>
+        </p:txBody>
+      </p:sp>
+      <p:sp>
+        <p:nvSpPr>
+          <p:cNvPr id="4" name="Text 2"/>
+          <p:cNvSpPr/>
+          <p:nvPr/>
+        </p:nvSpPr>
+        <p:spPr>
+          <a:xfrm>
+            <a:off x="548640" y="1371600"/>
+            <a:ext cx="4023360" cy="365760"/>
+          </a:xfrm>
+          <a:prstGeom prst="rect">
+            <a:avLst/>
+          </a:prstGeom>
+          <a:noFill/>
+          <a:ln/>
+        </p:spPr>
+        <p:txBody>
+          <a:bodyPr wrap="square" lIns="0" tIns="0" rIns="0" bIns="0" rtlCol="0" anchor="ctr"/>
+          <a:lstStyle/>
+          <a:p>
+            <a:pPr indent="0" marL="0">
+              <a:buNone/>
+            </a:pPr>
+            <a:r>
+              <a:rPr lang="en-US" sz="1600" b="1" dirty="0">
+                <a:solidFill>
+                  <a:srgbClr val="1E2761"/>
+                </a:solidFill>
+                <a:latin typeface="Calibri" pitchFamily="34" charset="0"/>
+                <a:ea typeface="Calibri" pitchFamily="34" charset="-122"/>
+                <a:cs typeface="Calibri" pitchFamily="34" charset="-120"/>
+              </a:rPr>
+              <a:t>How It Works</a:t>
+            </a:r>
+            <a:endParaRPr lang="en-US" sz="1600" dirty="0"/>
+          </a:p>
+        </p:txBody>
+      </p:sp>
+      <p:sp>
+        <p:nvSpPr>
+          <p:cNvPr id="5" name="Shape 3"/>
+          <p:cNvSpPr/>
+          <p:nvPr/>
+        </p:nvSpPr>
+        <p:spPr>
+          <a:xfrm>
+            <a:off x="548640" y="1801368"/>
+            <a:ext cx="256032" cy="256032"/>
+          </a:xfrm>
+          <a:prstGeom prst="ellipse">
+            <a:avLst/>
+          </a:prstGeom>
+          <a:solidFill>
+            <a:srgbClr val="00D4FF"/>
+          </a:solidFill>
+          <a:ln/>
+        </p:spPr>
+      </p:sp>
+      <p:sp>
+        <p:nvSpPr>
+          <p:cNvPr id="6" name="Text 4"/>
+          <p:cNvSpPr/>
+          <p:nvPr/>
+        </p:nvSpPr>
+        <p:spPr>
+          <a:xfrm>
+            <a:off x="548640" y="1801368"/>
+            <a:ext cx="256032" cy="256032"/>
+          </a:xfrm>
+          <a:prstGeom prst="rect">
+            <a:avLst/>
+          </a:prstGeom>
+          <a:noFill/>
+          <a:ln/>
+        </p:spPr>
+        <p:txBody>
+          <a:bodyPr wrap="square" lIns="0" tIns="0" rIns="0" bIns="0" rtlCol="0" anchor="ctr"/>
+          <a:lstStyle/>
+          <a:p>
+            <a:pPr algn="ctr" indent="0" marL="0">
+              <a:buNone/>
+            </a:pPr>
+            <a:r>
+              <a:rPr lang="en-US" sz="1200" b="1" dirty="0">
+                <a:solidFill>
+                  <a:srgbClr val="141B3D"/>
+                </a:solidFill>
+                <a:latin typeface="Calibri" pitchFamily="34" charset="0"/>
+                <a:ea typeface="Calibri" pitchFamily="34" charset="-122"/>
+                <a:cs typeface="Calibri" pitchFamily="34" charset="-120"/>
+              </a:rPr>
+              <a:t>1</a:t>
+            </a:r>
+            <a:endParaRPr lang="en-US" sz="1200" dirty="0"/>
+          </a:p>
+        </p:txBody>
+      </p:sp>
+      <p:sp>
+        <p:nvSpPr>
+          <p:cNvPr id="7" name="Text 5"/>
+          <p:cNvSpPr/>
+          <p:nvPr/>
+        </p:nvSpPr>
+        <p:spPr>
+          <a:xfrm>
+            <a:off x="914400" y="1783080"/>
+            <a:ext cx="2194560" cy="292608"/>
+          </a:xfrm>
+          <a:prstGeom prst="rect">
+            <a:avLst/>
+          </a:prstGeom>
+          <a:noFill/>
+          <a:ln/>
+        </p:spPr>
+        <p:txBody>
+          <a:bodyPr wrap="square" lIns="0" tIns="0" rIns="0" bIns="0" rtlCol="0" anchor="ctr"/>
+          <a:lstStyle/>
+          <a:p>
+            <a:pPr indent="0" marL="0">
+              <a:buNone/>
+            </a:pPr>
+            <a:r>
+              <a:rPr lang="en-US" sz="1200" b="1" dirty="0">
+                <a:solidFill>
+                  <a:srgbClr val="1E2761"/>
+                </a:solidFill>
+                <a:latin typeface="Calibri" pitchFamily="34" charset="0"/>
+                <a:ea typeface="Calibri" pitchFamily="34" charset="-122"/>
+                <a:cs typeface="Calibri" pitchFamily="34" charset="-120"/>
+              </a:rPr>
+              <a:t>Trigger arrives (GP45)</a:t>
+            </a:r>
+            <a:endParaRPr lang="en-US" sz="1200" dirty="0"/>
+          </a:p>
+        </p:txBody>
+      </p:sp>
+      <p:sp>
+        <p:nvSpPr>
+          <p:cNvPr id="8" name="Text 6"/>
+          <p:cNvSpPr/>
+          <p:nvPr/>
+        </p:nvSpPr>
+        <p:spPr>
+          <a:xfrm>
+            <a:off x="3108960" y="1783080"/>
+            <a:ext cx="1645920" cy="292608"/>
+          </a:xfrm>
+          <a:prstGeom prst="rect">
+            <a:avLst/>
+          </a:prstGeom>
+          <a:noFill/>
+          <a:ln/>
+        </p:spPr>
+        <p:txBody>
+          <a:bodyPr wrap="square" lIns="0" tIns="0" rIns="0" bIns="0" rtlCol="0" anchor="ctr"/>
+          <a:lstStyle/>
+          <a:p>
+            <a:pPr indent="0" marL="0">
+              <a:buNone/>
+            </a:pPr>
+            <a:r>
+              <a:rPr lang="en-US" sz="1000" dirty="0">
+                <a:solidFill>
+                  <a:srgbClr val="8899AA"/>
+                </a:solidFill>
+                <a:latin typeface="Calibri" pitchFamily="34" charset="0"/>
+                <a:ea typeface="Calibri" pitchFamily="34" charset="-122"/>
+                <a:cs typeface="Calibri" pitchFamily="34" charset="-120"/>
+              </a:rPr>
+              <a:t>External 8 kHz pulse from microscope</a:t>
+            </a:r>
+            <a:endParaRPr lang="en-US" sz="1000" dirty="0"/>
+          </a:p>
+        </p:txBody>
+      </p:sp>
+      <p:sp>
+        <p:nvSpPr>
+          <p:cNvPr id="9" name="Shape 7"/>
+          <p:cNvSpPr/>
+          <p:nvPr/>
+        </p:nvSpPr>
+        <p:spPr>
+          <a:xfrm>
+            <a:off x="548640" y="2139696"/>
+            <a:ext cx="256032" cy="256032"/>
+          </a:xfrm>
+          <a:prstGeom prst="ellipse">
+            <a:avLst/>
+          </a:prstGeom>
+          <a:solidFill>
+            <a:srgbClr val="00D4FF"/>
+          </a:solidFill>
+          <a:ln/>
+        </p:spPr>
+      </p:sp>
+      <p:sp>
+        <p:nvSpPr>
+          <p:cNvPr id="10" name="Text 8"/>
+          <p:cNvSpPr/>
+          <p:nvPr/>
+        </p:nvSpPr>
+        <p:spPr>
+          <a:xfrm>
+            <a:off x="548640" y="2139696"/>
+            <a:ext cx="256032" cy="256032"/>
+          </a:xfrm>
+          <a:prstGeom prst="rect">
+            <a:avLst/>
+          </a:prstGeom>
+          <a:noFill/>
+          <a:ln/>
+        </p:spPr>
+        <p:txBody>
+          <a:bodyPr wrap="square" lIns="0" tIns="0" rIns="0" bIns="0" rtlCol="0" anchor="ctr"/>
+          <a:lstStyle/>
+          <a:p>
+            <a:pPr algn="ctr" indent="0" marL="0">
+              <a:buNone/>
+            </a:pPr>
+            <a:r>
+              <a:rPr lang="en-US" sz="1200" b="1" dirty="0">
+                <a:solidFill>
+                  <a:srgbClr val="141B3D"/>
+                </a:solidFill>
+                <a:latin typeface="Calibri" pitchFamily="34" charset="0"/>
+                <a:ea typeface="Calibri" pitchFamily="34" charset="-122"/>
+                <a:cs typeface="Calibri" pitchFamily="34" charset="-120"/>
+              </a:rPr>
+              <a:t>2</a:t>
+            </a:r>
+            <a:endParaRPr lang="en-US" sz="1200" dirty="0"/>
+          </a:p>
+        </p:txBody>
+      </p:sp>
+      <p:sp>
+        <p:nvSpPr>
+          <p:cNvPr id="11" name="Text 9"/>
+          <p:cNvSpPr/>
+          <p:nvPr/>
+        </p:nvSpPr>
+        <p:spPr>
+          <a:xfrm>
+            <a:off x="914400" y="2121408"/>
+            <a:ext cx="2194560" cy="292608"/>
+          </a:xfrm>
+          <a:prstGeom prst="rect">
+            <a:avLst/>
+          </a:prstGeom>
+          <a:noFill/>
+          <a:ln/>
+        </p:spPr>
+        <p:txBody>
+          <a:bodyPr wrap="square" lIns="0" tIns="0" rIns="0" bIns="0" rtlCol="0" anchor="ctr"/>
+          <a:lstStyle/>
+          <a:p>
+            <a:pPr indent="0" marL="0">
+              <a:buNone/>
+            </a:pPr>
+            <a:r>
+              <a:rPr lang="en-US" sz="1200" b="1" dirty="0">
+                <a:solidFill>
+                  <a:srgbClr val="1E2761"/>
+                </a:solidFill>
+                <a:latin typeface="Calibri" pitchFamily="34" charset="0"/>
+                <a:ea typeface="Calibri" pitchFamily="34" charset="-122"/>
+                <a:cs typeface="Calibri" pitchFamily="34" charset="-120"/>
+              </a:rPr>
+              <a:t>CPU activates row GPIO</a:t>
+            </a:r>
+            <a:endParaRPr lang="en-US" sz="1200" dirty="0"/>
+          </a:p>
+        </p:txBody>
+      </p:sp>
+      <p:sp>
+        <p:nvSpPr>
+          <p:cNvPr id="12" name="Text 10"/>
+          <p:cNvSpPr/>
+          <p:nvPr/>
+        </p:nvSpPr>
+        <p:spPr>
+          <a:xfrm>
+            <a:off x="3108960" y="2121408"/>
+            <a:ext cx="1645920" cy="292608"/>
+          </a:xfrm>
+          <a:prstGeom prst="rect">
+            <a:avLst/>
+          </a:prstGeom>
+          <a:noFill/>
+          <a:ln/>
+        </p:spPr>
+        <p:txBody>
+          <a:bodyPr wrap="square" lIns="0" tIns="0" rIns="0" bIns="0" rtlCol="0" anchor="ctr"/>
+          <a:lstStyle/>
+          <a:p>
+            <a:pPr indent="0" marL="0">
+              <a:buNone/>
+            </a:pPr>
+            <a:r>
+              <a:rPr lang="en-US" sz="1000" dirty="0">
+                <a:solidFill>
+                  <a:srgbClr val="8899AA"/>
+                </a:solidFill>
+                <a:latin typeface="Calibri" pitchFamily="34" charset="0"/>
+                <a:ea typeface="Calibri" pitchFamily="34" charset="-122"/>
+                <a:cs typeface="Calibri" pitchFamily="34" charset="-120"/>
+              </a:rPr>
+              <a:t>gpio_set_mask64() — one of 20 rows</a:t>
+            </a:r>
+            <a:endParaRPr lang="en-US" sz="1000" dirty="0"/>
+          </a:p>
+        </p:txBody>
+      </p:sp>
+      <p:sp>
+        <p:nvSpPr>
+          <p:cNvPr id="13" name="Shape 11"/>
+          <p:cNvSpPr/>
+          <p:nvPr/>
+        </p:nvSpPr>
+        <p:spPr>
+          <a:xfrm>
+            <a:off x="548640" y="2478024"/>
+            <a:ext cx="256032" cy="256032"/>
+          </a:xfrm>
+          <a:prstGeom prst="ellipse">
+            <a:avLst/>
+          </a:prstGeom>
+          <a:solidFill>
+            <a:srgbClr val="00D4FF"/>
+          </a:solidFill>
+          <a:ln/>
+        </p:spPr>
+      </p:sp>
+      <p:sp>
+        <p:nvSpPr>
+          <p:cNvPr id="14" name="Text 12"/>
+          <p:cNvSpPr/>
+          <p:nvPr/>
+        </p:nvSpPr>
+        <p:spPr>
+          <a:xfrm>
+            <a:off x="548640" y="2478024"/>
+            <a:ext cx="256032" cy="256032"/>
+          </a:xfrm>
+          <a:prstGeom prst="rect">
+            <a:avLst/>
+          </a:prstGeom>
+          <a:noFill/>
+          <a:ln/>
+        </p:spPr>
+        <p:txBody>
+          <a:bodyPr wrap="square" lIns="0" tIns="0" rIns="0" bIns="0" rtlCol="0" anchor="ctr"/>
+          <a:lstStyle/>
+          <a:p>
+            <a:pPr algn="ctr" indent="0" marL="0">
+              <a:buNone/>
+            </a:pPr>
+            <a:r>
+              <a:rPr lang="en-US" sz="1200" b="1" dirty="0">
+                <a:solidFill>
+                  <a:srgbClr val="141B3D"/>
+                </a:solidFill>
+                <a:latin typeface="Calibri" pitchFamily="34" charset="0"/>
+                <a:ea typeface="Calibri" pitchFamily="34" charset="-122"/>
+                <a:cs typeface="Calibri" pitchFamily="34" charset="-120"/>
+              </a:rPr>
+              <a:t>3</a:t>
+            </a:r>
+            <a:endParaRPr lang="en-US" sz="1200" dirty="0"/>
+          </a:p>
+        </p:txBody>
+      </p:sp>
+      <p:sp>
+        <p:nvSpPr>
+          <p:cNvPr id="15" name="Text 13"/>
+          <p:cNvSpPr/>
+          <p:nvPr/>
+        </p:nvSpPr>
+        <p:spPr>
+          <a:xfrm>
+            <a:off x="914400" y="2459736"/>
+            <a:ext cx="2194560" cy="292608"/>
+          </a:xfrm>
+          <a:prstGeom prst="rect">
+            <a:avLst/>
+          </a:prstGeom>
+          <a:noFill/>
+          <a:ln/>
+        </p:spPr>
+        <p:txBody>
+          <a:bodyPr wrap="square" lIns="0" tIns="0" rIns="0" bIns="0" rtlCol="0" anchor="ctr"/>
+          <a:lstStyle/>
+          <a:p>
+            <a:pPr indent="0" marL="0">
+              <a:buNone/>
+            </a:pPr>
+            <a:r>
+              <a:rPr lang="en-US" sz="1200" b="1" dirty="0">
+                <a:solidFill>
+                  <a:srgbClr val="1E2761"/>
+                </a:solidFill>
+                <a:latin typeface="Calibri" pitchFamily="34" charset="0"/>
+                <a:ea typeface="Calibri" pitchFamily="34" charset="-122"/>
+                <a:cs typeface="Calibri" pitchFamily="34" charset="-120"/>
+              </a:rPr>
+              <a:t>PIO drives 4 bit-planes</a:t>
+            </a:r>
+            <a:endParaRPr lang="en-US" sz="1200" dirty="0"/>
+          </a:p>
+        </p:txBody>
+      </p:sp>
+      <p:sp>
+        <p:nvSpPr>
+          <p:cNvPr id="16" name="Text 14"/>
+          <p:cNvSpPr/>
+          <p:nvPr/>
+        </p:nvSpPr>
+        <p:spPr>
+          <a:xfrm>
+            <a:off x="3108960" y="2459736"/>
+            <a:ext cx="1645920" cy="292608"/>
+          </a:xfrm>
+          <a:prstGeom prst="rect">
+            <a:avLst/>
+          </a:prstGeom>
+          <a:noFill/>
+          <a:ln/>
+        </p:spPr>
+        <p:txBody>
+          <a:bodyPr wrap="square" lIns="0" tIns="0" rIns="0" bIns="0" rtlCol="0" anchor="ctr"/>
+          <a:lstStyle/>
+          <a:p>
+            <a:pPr indent="0" marL="0">
+              <a:buNone/>
+            </a:pPr>
+            <a:r>
+              <a:rPr lang="en-US" sz="1000" dirty="0">
+                <a:solidFill>
+                  <a:srgbClr val="8899AA"/>
+                </a:solidFill>
+                <a:latin typeface="Calibri" pitchFamily="34" charset="0"/>
+                <a:ea typeface="Calibri" pitchFamily="34" charset="-122"/>
+                <a:cs typeface="Calibri" pitchFamily="34" charset="-120"/>
+              </a:rPr>
+              <a:t>out pins, 20 sets all columns in 1 cycle</a:t>
+            </a:r>
+            <a:endParaRPr lang="en-US" sz="1000" dirty="0"/>
+          </a:p>
+        </p:txBody>
+      </p:sp>
+      <p:sp>
+        <p:nvSpPr>
+          <p:cNvPr id="17" name="Text 15"/>
+          <p:cNvSpPr/>
+          <p:nvPr/>
+        </p:nvSpPr>
+        <p:spPr>
+          <a:xfrm>
+            <a:off x="1097280" y="2798064"/>
+            <a:ext cx="2194560" cy="292608"/>
+          </a:xfrm>
+          <a:prstGeom prst="rect">
+            <a:avLst/>
+          </a:prstGeom>
+          <a:noFill/>
+          <a:ln/>
+        </p:spPr>
+        <p:txBody>
+          <a:bodyPr wrap="square" lIns="0" tIns="0" rIns="0" bIns="0" rtlCol="0" anchor="ctr"/>
+          <a:lstStyle/>
+          <a:p>
+            <a:pPr indent="0" marL="0">
+              <a:buNone/>
+            </a:pPr>
+            <a:r>
+              <a:rPr lang="en-US" sz="1100" dirty="0">
+                <a:solidFill>
+                  <a:srgbClr val="8899AA"/>
+                </a:solidFill>
+                <a:latin typeface="Consolas" pitchFamily="34" charset="0"/>
+                <a:ea typeface="Consolas" pitchFamily="34" charset="-122"/>
+                <a:cs typeface="Consolas" pitchFamily="34" charset="-120"/>
+              </a:rPr>
+              <a:t>  B0: 0.5 µs  (weight 1)</a:t>
+            </a:r>
+            <a:endParaRPr lang="en-US" sz="1100" dirty="0"/>
+          </a:p>
+        </p:txBody>
+      </p:sp>
+      <p:sp>
+        <p:nvSpPr>
+          <p:cNvPr id="18" name="Text 16"/>
+          <p:cNvSpPr/>
+          <p:nvPr/>
+        </p:nvSpPr>
+        <p:spPr>
+          <a:xfrm>
+            <a:off x="1097280" y="3136392"/>
+            <a:ext cx="2194560" cy="292608"/>
+          </a:xfrm>
+          <a:prstGeom prst="rect">
+            <a:avLst/>
+          </a:prstGeom>
+          <a:noFill/>
+          <a:ln/>
+        </p:spPr>
+        <p:txBody>
+          <a:bodyPr wrap="square" lIns="0" tIns="0" rIns="0" bIns="0" rtlCol="0" anchor="ctr"/>
+          <a:lstStyle/>
+          <a:p>
+            <a:pPr indent="0" marL="0">
+              <a:buNone/>
+            </a:pPr>
+            <a:r>
+              <a:rPr lang="en-US" sz="1100" dirty="0">
+                <a:solidFill>
+                  <a:srgbClr val="8899AA"/>
+                </a:solidFill>
+                <a:latin typeface="Consolas" pitchFamily="34" charset="0"/>
+                <a:ea typeface="Consolas" pitchFamily="34" charset="-122"/>
+                <a:cs typeface="Consolas" pitchFamily="34" charset="-120"/>
+              </a:rPr>
+              <a:t>  B1: 1.0 µs  (weight 2)</a:t>
+            </a:r>
+            <a:endParaRPr lang="en-US" sz="1100" dirty="0"/>
+          </a:p>
+        </p:txBody>
+      </p:sp>
+      <p:sp>
+        <p:nvSpPr>
+          <p:cNvPr id="19" name="Text 17"/>
+          <p:cNvSpPr/>
+          <p:nvPr/>
+        </p:nvSpPr>
+        <p:spPr>
+          <a:xfrm>
+            <a:off x="1097280" y="3474720"/>
+            <a:ext cx="2194560" cy="292608"/>
+          </a:xfrm>
+          <a:prstGeom prst="rect">
+            <a:avLst/>
+          </a:prstGeom>
+          <a:noFill/>
+          <a:ln/>
+        </p:spPr>
+        <p:txBody>
+          <a:bodyPr wrap="square" lIns="0" tIns="0" rIns="0" bIns="0" rtlCol="0" anchor="ctr"/>
+          <a:lstStyle/>
+          <a:p>
+            <a:pPr indent="0" marL="0">
+              <a:buNone/>
+            </a:pPr>
+            <a:r>
+              <a:rPr lang="en-US" sz="1100" dirty="0">
+                <a:solidFill>
+                  <a:srgbClr val="8899AA"/>
+                </a:solidFill>
+                <a:latin typeface="Consolas" pitchFamily="34" charset="0"/>
+                <a:ea typeface="Consolas" pitchFamily="34" charset="-122"/>
+                <a:cs typeface="Consolas" pitchFamily="34" charset="-120"/>
+              </a:rPr>
+              <a:t>  B2: 2.0 µs  (weight 4)</a:t>
+            </a:r>
+            <a:endParaRPr lang="en-US" sz="1100" dirty="0"/>
+          </a:p>
+        </p:txBody>
+      </p:sp>
+      <p:sp>
+        <p:nvSpPr>
+          <p:cNvPr id="20" name="Text 18"/>
+          <p:cNvSpPr/>
+          <p:nvPr/>
+        </p:nvSpPr>
+        <p:spPr>
+          <a:xfrm>
+            <a:off x="1097280" y="3813048"/>
+            <a:ext cx="2194560" cy="292608"/>
+          </a:xfrm>
+          <a:prstGeom prst="rect">
+            <a:avLst/>
+          </a:prstGeom>
+          <a:noFill/>
+          <a:ln/>
+        </p:spPr>
+        <p:txBody>
+          <a:bodyPr wrap="square" lIns="0" tIns="0" rIns="0" bIns="0" rtlCol="0" anchor="ctr"/>
+          <a:lstStyle/>
+          <a:p>
+            <a:pPr indent="0" marL="0">
+              <a:buNone/>
+            </a:pPr>
+            <a:r>
+              <a:rPr lang="en-US" sz="1100" dirty="0">
+                <a:solidFill>
+                  <a:srgbClr val="8899AA"/>
+                </a:solidFill>
+                <a:latin typeface="Consolas" pitchFamily="34" charset="0"/>
+                <a:ea typeface="Consolas" pitchFamily="34" charset="-122"/>
+                <a:cs typeface="Consolas" pitchFamily="34" charset="-120"/>
+              </a:rPr>
+              <a:t>  B3: 4.0 µs  (weight 8)</a:t>
+            </a:r>
+            <a:endParaRPr lang="en-US" sz="1100" dirty="0"/>
+          </a:p>
+        </p:txBody>
+      </p:sp>
+      <p:sp>
+        <p:nvSpPr>
+          <p:cNvPr id="21" name="Shape 19"/>
+          <p:cNvSpPr/>
+          <p:nvPr/>
+        </p:nvSpPr>
+        <p:spPr>
+          <a:xfrm>
+            <a:off x="548640" y="4169664"/>
+            <a:ext cx="256032" cy="256032"/>
+          </a:xfrm>
+          <a:prstGeom prst="ellipse">
+            <a:avLst/>
+          </a:prstGeom>
+          <a:solidFill>
+            <a:srgbClr val="00D4FF"/>
+          </a:solidFill>
+          <a:ln/>
+        </p:spPr>
+      </p:sp>
+      <p:sp>
+        <p:nvSpPr>
+          <p:cNvPr id="22" name="Text 20"/>
+          <p:cNvSpPr/>
+          <p:nvPr/>
+        </p:nvSpPr>
+        <p:spPr>
+          <a:xfrm>
+            <a:off x="548640" y="4169664"/>
+            <a:ext cx="256032" cy="256032"/>
+          </a:xfrm>
+          <a:prstGeom prst="rect">
+            <a:avLst/>
+          </a:prstGeom>
+          <a:noFill/>
+          <a:ln/>
+        </p:spPr>
+        <p:txBody>
+          <a:bodyPr wrap="square" lIns="0" tIns="0" rIns="0" bIns="0" rtlCol="0" anchor="ctr"/>
+          <a:lstStyle/>
+          <a:p>
+            <a:pPr algn="ctr" indent="0" marL="0">
+              <a:buNone/>
+            </a:pPr>
+            <a:r>
+              <a:rPr lang="en-US" sz="1200" b="1" dirty="0">
+                <a:solidFill>
+                  <a:srgbClr val="141B3D"/>
+                </a:solidFill>
+                <a:latin typeface="Calibri" pitchFamily="34" charset="0"/>
+                <a:ea typeface="Calibri" pitchFamily="34" charset="-122"/>
+                <a:cs typeface="Calibri" pitchFamily="34" charset="-120"/>
+              </a:rPr>
+              <a:t>4</a:t>
+            </a:r>
+            <a:endParaRPr lang="en-US" sz="1200" dirty="0"/>
+          </a:p>
+        </p:txBody>
+      </p:sp>
+      <p:sp>
+        <p:nvSpPr>
+          <p:cNvPr id="23" name="Text 21"/>
+          <p:cNvSpPr/>
+          <p:nvPr/>
+        </p:nvSpPr>
+        <p:spPr>
+          <a:xfrm>
+            <a:off x="914400" y="4151376"/>
+            <a:ext cx="2194560" cy="292608"/>
+          </a:xfrm>
+          <a:prstGeom prst="rect">
+            <a:avLst/>
+          </a:prstGeom>
+          <a:noFill/>
+          <a:ln/>
+        </p:spPr>
+        <p:txBody>
+          <a:bodyPr wrap="square" lIns="0" tIns="0" rIns="0" bIns="0" rtlCol="0" anchor="ctr"/>
+          <a:lstStyle/>
+          <a:p>
+            <a:pPr indent="0" marL="0">
+              <a:buNone/>
+            </a:pPr>
+            <a:r>
+              <a:rPr lang="en-US" sz="1200" b="1" dirty="0">
+                <a:solidFill>
+                  <a:srgbClr val="1E2761"/>
+                </a:solidFill>
+                <a:latin typeface="Calibri" pitchFamily="34" charset="0"/>
+                <a:ea typeface="Calibri" pitchFamily="34" charset="-122"/>
+                <a:cs typeface="Calibri" pitchFamily="34" charset="-120"/>
+              </a:rPr>
+              <a:t>CPU deactivates row</a:t>
+            </a:r>
+            <a:endParaRPr lang="en-US" sz="1200" dirty="0"/>
+          </a:p>
+        </p:txBody>
+      </p:sp>
+      <p:sp>
+        <p:nvSpPr>
+          <p:cNvPr id="24" name="Text 22"/>
+          <p:cNvSpPr/>
+          <p:nvPr/>
+        </p:nvSpPr>
+        <p:spPr>
+          <a:xfrm>
+            <a:off x="3108960" y="4151376"/>
+            <a:ext cx="1645920" cy="292608"/>
+          </a:xfrm>
+          <a:prstGeom prst="rect">
+            <a:avLst/>
+          </a:prstGeom>
+          <a:noFill/>
+          <a:ln/>
+        </p:spPr>
+        <p:txBody>
+          <a:bodyPr wrap="square" lIns="0" tIns="0" rIns="0" bIns="0" rtlCol="0" anchor="ctr"/>
+          <a:lstStyle/>
+          <a:p>
+            <a:pPr indent="0" marL="0">
+              <a:buNone/>
+            </a:pPr>
+            <a:r>
+              <a:rPr lang="en-US" sz="1000" dirty="0">
+                <a:solidFill>
+                  <a:srgbClr val="8899AA"/>
+                </a:solidFill>
+                <a:latin typeface="Calibri" pitchFamily="34" charset="0"/>
+                <a:ea typeface="Calibri" pitchFamily="34" charset="-122"/>
+                <a:cs typeface="Calibri" pitchFamily="34" charset="-120"/>
+              </a:rPr>
+              <a:t>Total burst: 9.5 µs — fits 15 µs budget</a:t>
+            </a:r>
+            <a:endParaRPr lang="en-US" sz="1000" dirty="0"/>
+          </a:p>
+        </p:txBody>
+      </p:sp>
+      <p:sp>
+        <p:nvSpPr>
+          <p:cNvPr id="25" name="Shape 23"/>
+          <p:cNvSpPr/>
+          <p:nvPr/>
+        </p:nvSpPr>
+        <p:spPr>
+          <a:xfrm>
+            <a:off x="548640" y="4507992"/>
+            <a:ext cx="256032" cy="256032"/>
+          </a:xfrm>
+          <a:prstGeom prst="ellipse">
+            <a:avLst/>
+          </a:prstGeom>
+          <a:solidFill>
+            <a:srgbClr val="00D4FF"/>
+          </a:solidFill>
+          <a:ln/>
+        </p:spPr>
+      </p:sp>
+      <p:sp>
+        <p:nvSpPr>
+          <p:cNvPr id="26" name="Text 24"/>
+          <p:cNvSpPr/>
+          <p:nvPr/>
+        </p:nvSpPr>
+        <p:spPr>
+          <a:xfrm>
+            <a:off x="548640" y="4507992"/>
+            <a:ext cx="256032" cy="256032"/>
+          </a:xfrm>
+          <a:prstGeom prst="rect">
+            <a:avLst/>
+          </a:prstGeom>
+          <a:noFill/>
+          <a:ln/>
+        </p:spPr>
+        <p:txBody>
+          <a:bodyPr wrap="square" lIns="0" tIns="0" rIns="0" bIns="0" rtlCol="0" anchor="ctr"/>
+          <a:lstStyle/>
+          <a:p>
+            <a:pPr algn="ctr" indent="0" marL="0">
+              <a:buNone/>
+            </a:pPr>
+            <a:r>
+              <a:rPr lang="en-US" sz="1200" b="1" dirty="0">
+                <a:solidFill>
+                  <a:srgbClr val="141B3D"/>
+                </a:solidFill>
+                <a:latin typeface="Calibri" pitchFamily="34" charset="0"/>
+                <a:ea typeface="Calibri" pitchFamily="34" charset="-122"/>
+                <a:cs typeface="Calibri" pitchFamily="34" charset="-120"/>
+              </a:rPr>
+              <a:t>5</a:t>
+            </a:r>
+            <a:endParaRPr lang="en-US" sz="1200" dirty="0"/>
+          </a:p>
+        </p:txBody>
+      </p:sp>
+      <p:sp>
+        <p:nvSpPr>
+          <p:cNvPr id="27" name="Text 25"/>
+          <p:cNvSpPr/>
+          <p:nvPr/>
+        </p:nvSpPr>
+        <p:spPr>
+          <a:xfrm>
+            <a:off x="914400" y="4489704"/>
+            <a:ext cx="2194560" cy="292608"/>
+          </a:xfrm>
+          <a:prstGeom prst="rect">
+            <a:avLst/>
+          </a:prstGeom>
+          <a:noFill/>
+          <a:ln/>
+        </p:spPr>
+        <p:txBody>
+          <a:bodyPr wrap="square" lIns="0" tIns="0" rIns="0" bIns="0" rtlCol="0" anchor="ctr"/>
+          <a:lstStyle/>
+          <a:p>
+            <a:pPr indent="0" marL="0">
+              <a:buNone/>
+            </a:pPr>
+            <a:r>
+              <a:rPr lang="en-US" sz="1200" b="1" dirty="0">
+                <a:solidFill>
+                  <a:srgbClr val="1E2761"/>
+                </a:solidFill>
+                <a:latin typeface="Calibri" pitchFamily="34" charset="0"/>
+                <a:ea typeface="Calibri" pitchFamily="34" charset="-122"/>
+                <a:cs typeface="Calibri" pitchFamily="34" charset="-120"/>
+              </a:rPr>
+              <a:t>Idle: 115 µs</a:t>
+            </a:r>
+            <a:endParaRPr lang="en-US" sz="1200" dirty="0"/>
+          </a:p>
+        </p:txBody>
+      </p:sp>
+      <p:sp>
+        <p:nvSpPr>
+          <p:cNvPr id="28" name="Text 26"/>
+          <p:cNvSpPr/>
+          <p:nvPr/>
+        </p:nvSpPr>
+        <p:spPr>
+          <a:xfrm>
+            <a:off x="3108960" y="4489704"/>
+            <a:ext cx="1645920" cy="292608"/>
+          </a:xfrm>
+          <a:prstGeom prst="rect">
+            <a:avLst/>
+          </a:prstGeom>
+          <a:noFill/>
+          <a:ln/>
+        </p:spPr>
+        <p:txBody>
+          <a:bodyPr wrap="square" lIns="0" tIns="0" rIns="0" bIns="0" rtlCol="0" anchor="ctr"/>
+          <a:lstStyle/>
+          <a:p>
+            <a:pPr indent="0" marL="0">
+              <a:buNone/>
+            </a:pPr>
+            <a:r>
+              <a:rPr lang="en-US" sz="1000" dirty="0">
+                <a:solidFill>
+                  <a:srgbClr val="8899AA"/>
+                </a:solidFill>
+                <a:latin typeface="Calibri" pitchFamily="34" charset="0"/>
+                <a:ea typeface="Calibri" pitchFamily="34" charset="-122"/>
+                <a:cs typeface="Calibri" pitchFamily="34" charset="-120"/>
+              </a:rPr>
+              <a:t>SPI frame loading, precompute, USB</a:t>
+            </a:r>
+            <a:endParaRPr lang="en-US" sz="1000" dirty="0"/>
+          </a:p>
+        </p:txBody>
+      </p:sp>
+      <p:sp>
+        <p:nvSpPr>
+          <p:cNvPr id="29" name="Text 27"/>
+          <p:cNvSpPr/>
+          <p:nvPr/>
+        </p:nvSpPr>
+        <p:spPr>
+          <a:xfrm>
+            <a:off x="4846320" y="1371600"/>
+            <a:ext cx="3840480" cy="365760"/>
+          </a:xfrm>
+          <a:prstGeom prst="rect">
+            <a:avLst/>
+          </a:prstGeom>
+          <a:noFill/>
+          <a:ln/>
+        </p:spPr>
+        <p:txBody>
+          <a:bodyPr wrap="square" lIns="0" tIns="0" rIns="0" bIns="0" rtlCol="0" anchor="ctr"/>
+          <a:lstStyle/>
+          <a:p>
+            <a:pPr indent="0" marL="0">
+              <a:buNone/>
+            </a:pPr>
+            <a:r>
+              <a:rPr lang="en-US" sz="1600" b="1" dirty="0">
+                <a:solidFill>
+                  <a:srgbClr val="1E2761"/>
+                </a:solidFill>
+                <a:latin typeface="Calibri" pitchFamily="34" charset="0"/>
+                <a:ea typeface="Calibri" pitchFamily="34" charset="-122"/>
+                <a:cs typeface="Calibri" pitchFamily="34" charset="-120"/>
+              </a:rPr>
+              <a:t>Saleae Optical Validation</a:t>
+            </a:r>
+            <a:endParaRPr lang="en-US" sz="1600" dirty="0"/>
+          </a:p>
+        </p:txBody>
+      </p:sp>
+      <p:sp>
+        <p:nvSpPr>
+          <p:cNvPr id="30" name="Text 28"/>
+          <p:cNvSpPr/>
+          <p:nvPr/>
+        </p:nvSpPr>
+        <p:spPr>
+          <a:xfrm>
+            <a:off x="4846320" y="1737360"/>
+            <a:ext cx="3840480" cy="274320"/>
+          </a:xfrm>
+          <a:prstGeom prst="rect">
+            <a:avLst/>
+          </a:prstGeom>
+          <a:noFill/>
+          <a:ln/>
+        </p:spPr>
+        <p:txBody>
+          <a:bodyPr wrap="square" lIns="0" tIns="0" rIns="0" bIns="0" rtlCol="0" anchor="ctr"/>
+          <a:lstStyle/>
+          <a:p>
+            <a:pPr indent="0" marL="0">
+              <a:buNone/>
+            </a:pPr>
+            <a:r>
+              <a:rPr lang="en-US" sz="1100" dirty="0">
+                <a:solidFill>
+                  <a:srgbClr val="8899AA"/>
+                </a:solidFill>
+                <a:latin typeface="Calibri" pitchFamily="34" charset="0"/>
+                <a:ea typeface="Calibri" pitchFamily="34" charset="-122"/>
+                <a:cs typeface="Calibri" pitchFamily="34" charset="-120"/>
+              </a:rPr>
+              <a:t>499 pulses averaged at 50 MHz — BCM bit-plane structure confirmed</a:t>
+            </a:r>
+            <a:endParaRPr lang="en-US" sz="1100" dirty="0"/>
+          </a:p>
+        </p:txBody>
+      </p:sp>
+      <p:pic>
+        <p:nvPicPr>
+          <p:cNvPr id="31" name="Image 0" descr="preencoded.png">    </p:cNvPr>
+          <p:cNvPicPr>
+            <a:picLocks noChangeAspect="1"/>
+          </p:cNvPicPr>
+          <p:nvPr/>
+        </p:nvPicPr>
+        <p:blipFill>
+          <a:blip r:embed="rId1"/>
+          <a:stretch>
+            <a:fillRect/>
+          </a:stretch>
+        </p:blipFill>
+        <p:spPr>
+          <a:xfrm>
+            <a:off x="4754880" y="2103120"/>
+            <a:ext cx="4023360" cy="2011680"/>
+          </a:xfrm>
+          <a:prstGeom prst="rect">
+            <a:avLst/>
+          </a:prstGeom>
+        </p:spPr>
+      </p:pic>
+      <p:sp>
+        <p:nvSpPr>
+          <p:cNvPr id="32" name="Text 29"/>
+          <p:cNvSpPr/>
+          <p:nvPr/>
+        </p:nvSpPr>
+        <p:spPr>
+          <a:xfrm>
+            <a:off x="5303520" y="4114800"/>
+            <a:ext cx="2743200" cy="274320"/>
+          </a:xfrm>
+          <a:prstGeom prst="rect">
+            <a:avLst/>
+          </a:prstGeom>
+          <a:noFill/>
+          <a:ln/>
+        </p:spPr>
+        <p:txBody>
+          <a:bodyPr wrap="square" lIns="0" tIns="0" rIns="0" bIns="0" rtlCol="0" anchor="ctr"/>
+          <a:lstStyle/>
+          <a:p>
+            <a:pPr indent="0" marL="0">
+              <a:buNone/>
+            </a:pPr>
+            <a:r>
+              <a:rPr lang="en-US" sz="1100" dirty="0">
+                <a:solidFill>
+                  <a:srgbClr val="00D4FF"/>
+                </a:solidFill>
+                <a:latin typeface="Consolas" pitchFamily="34" charset="0"/>
+                <a:ea typeface="Consolas" pitchFamily="34" charset="-122"/>
+                <a:cs typeface="Consolas" pitchFamily="34" charset="-120"/>
+              </a:rPr>
+              <a:t>B0  B1   B2      B3</a:t>
+            </a:r>
+            <a:endParaRPr lang="en-US" sz="1100" dirty="0"/>
+          </a:p>
+        </p:txBody>
+      </p:sp>
+      <p:sp>
+        <p:nvSpPr>
+          <p:cNvPr id="33" name="Text 30"/>
+          <p:cNvSpPr/>
+          <p:nvPr/>
+        </p:nvSpPr>
+        <p:spPr>
+          <a:xfrm>
+            <a:off x="5486400" y="4343400"/>
+            <a:ext cx="2286000" cy="228600"/>
+          </a:xfrm>
+          <a:prstGeom prst="rect">
+            <a:avLst/>
+          </a:prstGeom>
+          <a:noFill/>
+          <a:ln/>
+        </p:spPr>
+        <p:txBody>
+          <a:bodyPr wrap="square" lIns="0" tIns="0" rIns="0" bIns="0" rtlCol="0" anchor="ctr"/>
+          <a:lstStyle/>
+          <a:p>
+            <a:pPr indent="0" marL="0">
+              <a:buNone/>
+            </a:pPr>
+            <a:r>
+              <a:rPr lang="en-US" sz="1000" dirty="0">
+                <a:solidFill>
+                  <a:srgbClr val="8899AA"/>
+                </a:solidFill>
+                <a:latin typeface="Consolas" pitchFamily="34" charset="0"/>
+                <a:ea typeface="Consolas" pitchFamily="34" charset="-122"/>
+                <a:cs typeface="Consolas" pitchFamily="34" charset="-120"/>
+              </a:rPr>
+              <a:t>← 9.5 µs burst →</a:t>
+            </a:r>
+            <a:endParaRPr lang="en-US" sz="1000" dirty="0"/>
+          </a:p>
+        </p:txBody>
+      </p:sp>
+      <p:sp>
+        <p:nvSpPr>
+          <p:cNvPr id="34" name="Shape 31"/>
+          <p:cNvSpPr/>
+          <p:nvPr/>
+        </p:nvSpPr>
+        <p:spPr>
+          <a:xfrm>
+            <a:off x="0" y="4800600"/>
+            <a:ext cx="9144000" cy="342900"/>
+          </a:xfrm>
+          <a:prstGeom prst="rect">
+            <a:avLst/>
+          </a:prstGeom>
+          <a:solidFill>
+            <a:srgbClr val="1E2761"/>
+          </a:solidFill>
+          <a:ln/>
+        </p:spPr>
+      </p:sp>
+      <p:sp>
+        <p:nvSpPr>
+          <p:cNvPr id="35" name="Text 32"/>
+          <p:cNvSpPr/>
+          <p:nvPr/>
+        </p:nvSpPr>
+        <p:spPr>
+          <a:xfrm>
+            <a:off x="457200" y="4818888"/>
+            <a:ext cx="8229600" cy="320040"/>
+          </a:xfrm>
+          <a:prstGeom prst="rect">
+            <a:avLst/>
+          </a:prstGeom>
+          <a:noFill/>
+          <a:ln/>
+        </p:spPr>
+        <p:txBody>
+          <a:bodyPr wrap="square" lIns="0" tIns="0" rIns="0" bIns="0" rtlCol="0" anchor="ctr"/>
+          <a:lstStyle/>
+          <a:p>
+            <a:pPr indent="0" marL="0">
+              <a:buNone/>
+            </a:pPr>
+            <a:r>
+              <a:rPr lang="en-US" sz="1200" b="1" dirty="0">
+                <a:solidFill>
+                  <a:srgbClr val="00D4FF"/>
+                </a:solidFill>
+                <a:latin typeface="Calibri" pitchFamily="34" charset="0"/>
+                <a:ea typeface="Calibri" pitchFamily="34" charset="-122"/>
+                <a:cs typeface="Calibri" pitchFamily="34" charset="-120"/>
+              </a:rPr>
+              <a:t>PIO out pins, 20 drives all columns in 1 clock cycle (6.67 ns) — CPU only manages row switching</a:t>
+            </a:r>
+            <a:endParaRPr lang="en-US" sz="1200" dirty="0"/>
+          </a:p>
+        </p:txBody>
+      </p:sp>
+    </p:spTree>
+  </p:cSld>
+  <p:clrMapOvr>
+    <a:masterClrMapping/>
+  </p:clrMapOvr>
+</p:sld>
+</file>
+
+<file path=ppt/slides/slide4.xml><?xml version="1.0" encoding="utf-8"?>
+<p:sld xmlns:a="http://schemas.openxmlformats.org/drawingml/2006/main" xmlns:r="http://schemas.openxmlformats.org/officeDocument/2006/relationships" xmlns:p="http://schemas.openxmlformats.org/presentationml/2006/main">
+  <p:cSld name="Slide 4">
+    <p:bg>
+      <p:bgPr>
+        <a:solidFill>
+          <a:srgbClr val="FFFFFF"/>
+        </a:solidFill>
+      </p:bgPr>
+    </p:bg>
+    <p:spTree>
+      <p:nvGrpSpPr>
+        <p:cNvPr id="1" name=""/>
+        <p:cNvGrpSpPr/>
+        <p:nvPr/>
+      </p:nvGrpSpPr>
+      <p:grpSpPr>
+        <a:xfrm>
+          <a:off x="0" y="0"/>
+          <a:ext cx="0" cy="0"/>
+          <a:chOff x="0" y="0"/>
+          <a:chExt cx="0" cy="0"/>
+        </a:xfrm>
+      </p:grpSpPr>
+      <p:sp>
+        <p:nvSpPr>
+          <p:cNvPr id="2" name="Text 0"/>
+          <p:cNvSpPr/>
+          <p:nvPr/>
+        </p:nvSpPr>
+        <p:spPr>
+          <a:xfrm>
+            <a:off x="548640" y="274320"/>
+            <a:ext cx="8229600" cy="640080"/>
+          </a:xfrm>
+          <a:prstGeom prst="rect">
+            <a:avLst/>
+          </a:prstGeom>
+          <a:noFill/>
+          <a:ln/>
+        </p:spPr>
+        <p:txBody>
+          <a:bodyPr wrap="square" lIns="0" tIns="0" rIns="0" bIns="0" rtlCol="0" anchor="ctr"/>
+          <a:lstStyle/>
+          <a:p>
+            <a:pPr indent="0" marL="0">
+              <a:buNone/>
+            </a:pPr>
+            <a:r>
+              <a:rPr lang="en-US" sz="3200" b="1" dirty="0">
+                <a:solidFill>
+                  <a:srgbClr val="1E2761"/>
+                </a:solidFill>
+                <a:latin typeface="Arial Black" pitchFamily="34" charset="0"/>
+                <a:ea typeface="Arial Black" pitchFamily="34" charset="-122"/>
+                <a:cs typeface="Arial Black" pitchFamily="34" charset="-120"/>
+              </a:rPr>
+              <a:t>BCM Burst Timing — All Configurations</a:t>
+            </a:r>
+            <a:endParaRPr lang="en-US" sz="3200" dirty="0"/>
+          </a:p>
+        </p:txBody>
+      </p:sp>
+      <p:sp>
+        <p:nvSpPr>
+          <p:cNvPr id="3" name="Text 1"/>
+          <p:cNvSpPr/>
+          <p:nvPr/>
+        </p:nvSpPr>
+        <p:spPr>
+          <a:xfrm>
+            <a:off x="548640" y="822960"/>
+            <a:ext cx="8229600" cy="365760"/>
+          </a:xfrm>
+          <a:prstGeom prst="rect">
+            <a:avLst/>
+          </a:prstGeom>
+          <a:noFill/>
+          <a:ln/>
+        </p:spPr>
+        <p:txBody>
+          <a:bodyPr wrap="square" lIns="0" tIns="0" rIns="0" bIns="0" rtlCol="0" anchor="ctr"/>
+          <a:lstStyle/>
+          <a:p>
+            <a:pPr indent="0" marL="0">
+              <a:buNone/>
+            </a:pPr>
+            <a:r>
+              <a:rPr lang="en-US" sz="1400" i="1" dirty="0">
+                <a:solidFill>
+                  <a:srgbClr val="8899AA"/>
+                </a:solidFill>
+                <a:latin typeface="Calibri" pitchFamily="34" charset="0"/>
+                <a:ea typeface="Calibri" pitchFamily="34" charset="-122"/>
+                <a:cs typeface="Calibri" pitchFamily="34" charset="-120"/>
+              </a:rPr>
               <a:t>4-bit BCM, 16 intensities × 4 base times × 10,000 frames at 8 kHz</a:t>
             </a:r>
             <a:endParaRPr lang="en-US" sz="1400" dirty="0"/>
@@ -3037,7 +4355,7 @@
       </p:sp>
       <p:graphicFrame>
         <p:nvGraphicFramePr>
-          <p:cNvPr id="4" name="Table 0"/>
+          <p:cNvPr id="5" name="Table 0"/>
           <p:cNvGraphicFramePr>
             <a:graphicFrameLocks noGrp="1"/>
           </p:cNvGraphicFramePr>
@@ -5148,9 +6466,9 @@
 </p:sld>
 </file>
 
-<file path=ppt/slides/slide4.xml><?xml version="1.0" encoding="utf-8"?>
+<file path=ppt/slides/slide5.xml><?xml version="1.0" encoding="utf-8"?>
 <p:sld xmlns:a="http://schemas.openxmlformats.org/drawingml/2006/main" xmlns:r="http://schemas.openxmlformats.org/officeDocument/2006/relationships" xmlns:p="http://schemas.openxmlformats.org/presentationml/2006/main">
-  <p:cSld name="Slide 4">
+  <p:cSld name="Slide 5">
     <p:bg>
       <p:bgPr>
         <a:solidFill>

</xml_diff>